<commit_message>
Level 5 Lesson 12 draft listening audio (2:17)
</commit_message>
<xml_diff>
--- a/level5/slides/Level5_Lesson12_Slides.pptx
+++ b/level5/slides/Level5_Lesson12_Slides.pptx
@@ -8,32 +8,32 @@
     <p:notesMasterId r:id="rId22"/>
   </p:notesMasterIdLst>
   <p:sldIdLst>
-    <p:sldId id="939" r:id="rId33"/>
-    <p:sldId id="940" r:id="rId34"/>
-    <p:sldId id="941" r:id="rId35"/>
-    <p:sldId id="942" r:id="rId36"/>
-    <p:sldId id="943" r:id="rId31"/>
-    <p:sldId id="944" r:id="rId30"/>
-    <p:sldId id="945" r:id="rId29"/>
-    <p:sldId id="946" r:id="rId28"/>
-    <p:sldId id="947" r:id="rId27"/>
-    <p:sldId id="948" r:id="rId20"/>
-    <p:sldId id="949" r:id="rId18"/>
-    <p:sldId id="950" r:id="rId17"/>
-    <p:sldId id="951" r:id="rId16"/>
-    <p:sldId id="952" r:id="rId14"/>
-    <p:sldId id="953" r:id="rId13"/>
-    <p:sldId id="954" r:id="rId12"/>
-    <p:sldId id="955" r:id="rId11"/>
-    <p:sldId id="956" r:id="rId10"/>
-    <p:sldId id="957" r:id="rId8"/>
-    <p:sldId id="958" r:id="rId7"/>
-    <p:sldId id="959" r:id="rId6"/>
-    <p:sldId id="960" r:id="rId5"/>
-    <p:sldId id="961" r:id="rId4"/>
-    <p:sldId id="962" r:id="rId3"/>
-    <p:sldId id="963" r:id="rId57"/>
-    <p:sldId id="964" r:id="rId2"/>
+    <p:sldId id="1095" r:id="rId33"/>
+    <p:sldId id="1096" r:id="rId34"/>
+    <p:sldId id="1097" r:id="rId35"/>
+    <p:sldId id="1098" r:id="rId36"/>
+    <p:sldId id="1099" r:id="rId31"/>
+    <p:sldId id="1100" r:id="rId30"/>
+    <p:sldId id="1101" r:id="rId29"/>
+    <p:sldId id="1102" r:id="rId28"/>
+    <p:sldId id="1103" r:id="rId27"/>
+    <p:sldId id="1104" r:id="rId20"/>
+    <p:sldId id="1105" r:id="rId18"/>
+    <p:sldId id="1106" r:id="rId17"/>
+    <p:sldId id="1107" r:id="rId16"/>
+    <p:sldId id="1108" r:id="rId14"/>
+    <p:sldId id="1109" r:id="rId13"/>
+    <p:sldId id="1110" r:id="rId12"/>
+    <p:sldId id="1111" r:id="rId11"/>
+    <p:sldId id="1112" r:id="rId10"/>
+    <p:sldId id="1113" r:id="rId8"/>
+    <p:sldId id="1114" r:id="rId7"/>
+    <p:sldId id="1115" r:id="rId6"/>
+    <p:sldId id="1116" r:id="rId5"/>
+    <p:sldId id="1117" r:id="rId4"/>
+    <p:sldId id="1118" r:id="rId3"/>
+    <p:sldId id="1119" r:id="rId57"/>
+    <p:sldId id="1120" r:id="rId2"/>
   </p:sldIdLst>
   <p:sldSz cx="12192000" cy="6858000"/>
   <p:notesSz cx="6858000" cy="12192000"/>
@@ -536,7 +536,7 @@
           </a:p>
           <a:p>
             <a:r>
-              <a:t>Audio: the listening audio for this lesson (about 2:35) is coming soon. It will use computer-generated voices (Chatterbox TTS cloned from synthetic Kokoro-82M reference clips); no recordings of real people. Until it is ready, read the listening script (in the notes of the Before You Listen slide) with a volunteer. The names and the story are invented.</a:t>
+              <a:t>Audio: synthetic voices, computer-generated (Chatterbox TTS cloned from Kokoro-82M reference clips). No recordings of real people. The names and the story are invented.</a:t>
             </a:r>
           </a:p>
           <a:p>
@@ -1417,116 +1417,6 @@
           <a:p>
             <a:r>
               <a:t>Picture: Twemoji graphics by Twitter, Inc. and other contributors (https://github.com/jdecked/twemoji), CC BY 4.0 (https://creativecommons.org/licenses/by/4.0/); resized and combined, with signs and labels (images/CREDITS.md).</a:t>
-            </a:r>
-          </a:p>
-          <a:p>
-            <a:r>
-              <a:t>Listening script (the audio is coming soon; until then, read it aloud with a volunteer at a normal, friendly speed):</a:t>
-            </a:r>
-          </a:p>
-          <a:p>
-            <a:r>
-              <a:t>Narrator: Lesson twelve. This is a short meeting at the library. Ms. Adeyemi is the chairperson. Tom and Grace are going to talk about evening hours.</a:t>
-            </a:r>
-          </a:p>
-          <a:p>
-            <a:r>
-              <a:t>Ms. Adeyemi: Welcome. Please look at the agenda, which is on your handout. This is the room where we meet.</a:t>
-            </a:r>
-          </a:p>
-          <a:p>
-            <a:r>
-              <a:t>Tom: I want to speak about the proposal. I want later hours.</a:t>
-            </a:r>
-          </a:p>
-          <a:p>
-            <a:r>
-              <a:t>Grace: I see your point, but I want to keep the current hours. The bus I take stops early.</a:t>
-            </a:r>
-          </a:p>
-          <a:p>
-            <a:r>
-              <a:t>Ms. Adeyemi: The proposal which I read is on page 2. It says a one-month try.</a:t>
-            </a:r>
-          </a:p>
-          <a:p>
-            <a:r>
-              <a:t>Tom: The library which we use closes at six. I want it open until eight.</a:t>
-            </a:r>
-          </a:p>
-          <a:p>
-            <a:r>
-              <a:t>Grace: The stop where I catch the bus is dark after seven. That is my reason.</a:t>
-            </a:r>
-          </a:p>
-          <a:p>
-            <a:r>
-              <a:t>Ms. Adeyemi: The person who takes notes is writing the minutes. Please use the microphone when you speak.</a:t>
-            </a:r>
-          </a:p>
-          <a:p>
-            <a:r>
-              <a:t>Tom: I think a one-month try is fair. I'm going to come after work on Thursday.</a:t>
-            </a:r>
-          </a:p>
-          <a:p>
-            <a:r>
-              <a:t>Grace: I see your point, but I need a safe ride. I can try it where the evening bus still runs.</a:t>
-            </a:r>
-          </a:p>
-          <a:p>
-            <a:r>
-              <a:t>Ms. Adeyemi: Please take a question card. Tom, which hours do you want?</a:t>
-            </a:r>
-          </a:p>
-          <a:p>
-            <a:r>
-              <a:t>Tom: I want eight o'clock on Thursday only. I want to keep the change small.</a:t>
-            </a:r>
-          </a:p>
-          <a:p>
-            <a:r>
-              <a:t>Grace: I can agree to Thursday if the sign-in sheet shows how many people come.</a:t>
-            </a:r>
-          </a:p>
-          <a:p>
-            <a:r>
-              <a:t>Ms. Adeyemi: Our decision is a one-month try on Thursday, until eight. The timer says we should stop.</a:t>
-            </a:r>
-          </a:p>
-          <a:p>
-            <a:r>
-              <a:t>Tom: My name tent is on the table, so the minutes can show who spoke.</a:t>
-            </a:r>
-          </a:p>
-          <a:p>
-            <a:r>
-              <a:t>Grace: The auditorium is too big. This library room is the place where we should meet.</a:t>
-            </a:r>
-          </a:p>
-          <a:p>
-            <a:r>
-              <a:t>Ms. Adeyemi: I am going to put the decision in the minutes. Thank you for a calm meeting.</a:t>
-            </a:r>
-          </a:p>
-          <a:p>
-            <a:r>
-              <a:t>Tom: I want to ask one question. Which bus still runs at eight?</a:t>
-            </a:r>
-          </a:p>
-          <a:p>
-            <a:r>
-              <a:t>Grace: The bus where I get off stops at seven. Thursday is the only day I can try.</a:t>
-            </a:r>
-          </a:p>
-          <a:p>
-            <a:r>
-              <a:t>Ms. Adeyemi: Then Thursday is the try. We are not going to move the meeting to the auditorium.</a:t>
-            </a:r>
-          </a:p>
-          <a:p>
-            <a:r>
-              <a:t>Narrator: That's the end of the listening.</a:t>
             </a:r>
           </a:p>
         </p:txBody>
@@ -9341,7 +9231,7 @@
             <a:r>
               <a:rPr lang="en-US" sz="2800" dirty="0" b="1">
                 <a:solidFill>
-                  <a:srgbClr val="1B2236"/>
+                  <a:srgbClr val="5B3FC4"/>
                 </a:solidFill>
                 <a:latin typeface="Lexend Deca" pitchFamily="34" charset="0"/>
                 <a:ea typeface="Lexend Deca" pitchFamily="34" charset="-122"/>
@@ -9388,7 +9278,7 @@
             <a:r>
               <a:rPr lang="en-US" sz="2800" dirty="0" b="1">
                 <a:solidFill>
-                  <a:srgbClr val="1B2236"/>
+                  <a:srgbClr val="5B3FC4"/>
                 </a:solidFill>
                 <a:latin typeface="Lexend Deca" pitchFamily="34" charset="0"/>
                 <a:ea typeface="Lexend Deca" pitchFamily="34" charset="-122"/>
@@ -10490,7 +10380,7 @@
                 <a:ea typeface="Lexend Deca" pitchFamily="34" charset="-122"/>
                 <a:cs typeface="Lexend Deca" pitchFamily="34" charset="-120"/>
               </a:rPr>
-              <a:t>Audio (about 2:35): coming soon.</a:t>
+              <a:t>Audio: about 2:17. It plays once.</a:t>
             </a:r>
             <a:endParaRPr lang="en-US" sz="2200" dirty="0"/>
           </a:p>
@@ -28875,7 +28765,7 @@
                 <a:ea typeface="Lexend Deca" pitchFamily="34" charset="-122"/>
                 <a:cs typeface="Lexend Deca" pitchFamily="34" charset="-120"/>
               </a:rPr>
-              <a:t>Audio (coming soon): synthetic voices made with Chatterbox TTS (MIT License), cloned from short synthetic reference clips made with Kokoro-82M (Apache License 2.0). No recordings of real people. Each file will carry an inaudible Perth watermark marking it as AI-generated. Font: Lexend Deca (OFL 1.1).</a:t>
+              <a:t>Audio: synthetic voices made with Chatterbox TTS (MIT License), cloned from short synthetic reference clips made with Kokoro-82M (Apache License 2.0). No recordings of real people were used. Each file carries an inaudible Perth watermark marking it as AI-generated. Font: Lexend Deca (OFL 1.1).</a:t>
             </a:r>
             <a:endParaRPr lang="en-US" sz="1350" dirty="0" b="0"/>
           </a:p>

</xml_diff>